<commit_message>
feat: Tesseract OCR 1순위 추가
- server/tesseract-ocr.py 생성 (한국어+영어, PSM 6)
- modules/ocr/ocr-engine.ts: Tesseract 우선 시도
- modules/ocr/index.ts: OCR → Vision 폴백 로직
- 순서: Tesseract (빠름) → Vision (상세)
- v2.5.0 버전 스냅샷 저장

Co-Authored-By: Claude Opus 4.6 <noreply@anthropic.com>
</commit_message>
<xml_diff>
--- a/docs/daily-reports/roadmap_20260428.pptx
+++ b/docs/daily-reports/roadmap_20260428.pptx
@@ -1061,7 +1061,7 @@
                 <a:ea typeface="Arial" pitchFamily="34" charset="-122"/>
                 <a:cs typeface="Arial" pitchFamily="34" charset="-120"/>
               </a:rPr>
-              <a:t>2026-04-27  |  v2.4.0</a:t>
+              <a:t>2026-04-28  |  v2.4.1</a:t>
             </a:r>
             <a:endParaRPr lang="en-US" sz="1000" dirty="0"/>
           </a:p>
@@ -2894,7 +2894,7 @@
                 <a:ea typeface="Arial" pitchFamily="34" charset="-122"/>
                 <a:cs typeface="Arial" pitchFamily="34" charset="-120"/>
               </a:rPr>
-              <a:t>v2.4.0</a:t>
+              <a:t>v2.4.1</a:t>
             </a:r>
             <a:endParaRPr lang="en-US" sz="2000" dirty="0"/>
           </a:p>
@@ -3380,7 +3380,7 @@
                 <a:ea typeface="Arial" pitchFamily="34" charset="-122"/>
                 <a:cs typeface="Arial" pitchFamily="34" charset="-120"/>
               </a:rPr>
-              <a:t>2026-04-27</a:t>
+              <a:t>2026-04-28</a:t>
             </a:r>
             <a:endParaRPr lang="en-US" sz="1000" dirty="0"/>
           </a:p>

</xml_diff>